<commit_message>
Bake circular mask into editable flyer photo
Co-Authored-By: Claude Sonnet 5.5 <noreply@anthropic.com>
Claude-Session: https://claude.ai/code/session_01U3WxEK2yMyoZ5jbgGHEui1
</commit_message>
<xml_diff>
--- a/art/editable/flyer-ingredientes-editavel.pptx
+++ b/art/editable/flyer-ingredientes-editavel.pptx
@@ -3492,10 +3492,10 @@
         </p:blipFill>
         <p:spPr>
           <a:xfrm>
-            <a:off x="7029450" y="5429250"/>
-            <a:ext cx="2667000" cy="2667000"/>
-          </a:xfrm>
-          <a:prstGeom prst="ellipse">
+            <a:off x="6934200" y="5334000"/>
+            <a:ext cx="2857500" cy="2857500"/>
+          </a:xfrm>
+          <a:prstGeom prst="rect">
             <a:avLst/>
           </a:prstGeom>
         </p:spPr>

</xml_diff>